<commit_message>
Add a sequence diagram of how the code runs over time
The static schematic shows what the pieces are; this shows the order they happen in,
which is what carries the claim. Four lanes against one clock: the video feed ticking
every stride, the audio feed starting later at the same cadence, the per-window call,
and what comes back. The call box is drawn identically on both sides of the moment the
second channel connects, because it is the same call -- only the recording list
changes. Added to the deck as 'How it runs'.
</commit_message>
<xml_diff>
--- a/scripts/streaming_demo_output/streaming_deck.pptx
+++ b/scripts/streaming_demo_output/streaming_deck.pptx
@@ -9,6 +9,7 @@
     <p:sldId id="257" r:id="rId8"/>
     <p:sldId id="258" r:id="rId9"/>
     <p:sldId id="259" r:id="rId10"/>
+    <p:sldId id="260" r:id="rId11"/>
   </p:sldIdLst>
   <p:sldSz cx="12191695" cy="6858000" type="screen4x3"/>
   <p:notesSz cx="6858000" cy="9144000"/>
@@ -3376,6 +3377,118 @@
               </a:defRPr>
             </a:pPr>
             <a:r>
+              <a:t>How it runs</a:t>
+            </a:r>
+          </a:p>
+        </p:txBody>
+      </p:sp>
+      <p:pic>
+        <p:nvPicPr>
+          <p:cNvPr id="3" name="Picture 2" descr="sequence.png"/>
+          <p:cNvPicPr>
+            <a:picLocks noChangeAspect="1"/>
+          </p:cNvPicPr>
+          <p:nvPr/>
+        </p:nvPicPr>
+        <p:blipFill>
+          <a:blip r:embed="rId2"/>
+          <a:stretch>
+            <a:fillRect/>
+          </a:stretch>
+        </p:blipFill>
+        <p:spPr>
+          <a:xfrm>
+            <a:off x="548640" y="777240"/>
+            <a:ext cx="11064240" cy="5693522"/>
+          </a:xfrm>
+          <a:prstGeom prst="rect">
+            <a:avLst/>
+          </a:prstGeom>
+        </p:spPr>
+      </p:pic>
+      <p:sp>
+        <p:nvSpPr>
+          <p:cNvPr id="4" name="TextBox 3"/>
+          <p:cNvSpPr txBox="1"/>
+          <p:nvPr/>
+        </p:nvSpPr>
+        <p:spPr>
+          <a:xfrm>
+            <a:off x="457200" y="6309360"/>
+            <a:ext cx="11247120" cy="457200"/>
+          </a:xfrm>
+          <a:prstGeom prst="rect">
+            <a:avLst/>
+          </a:prstGeom>
+          <a:noFill/>
+        </p:spPr>
+        <p:txBody>
+          <a:bodyPr wrap="square">
+            <a:spAutoFit/>
+          </a:bodyPr>
+          <a:lstStyle/>
+          <a:p>
+            <a:pPr>
+              <a:defRPr sz="1200" b="0">
+                <a:solidFill>
+                  <a:srgbClr val="8792A8"/>
+                </a:solidFill>
+              </a:defRPr>
+            </a:pPr>
+            <a:r>
+              <a:t>The per-window call is the same before and after the second channel joins; only the recording list changes.</a:t>
+            </a:r>
+          </a:p>
+        </p:txBody>
+      </p:sp>
+    </p:spTree>
+  </p:cSld>
+  <p:clrMapOvr>
+    <a:masterClrMapping/>
+  </p:clrMapOvr>
+</p:sld>
+</file>
+
+<file path=ppt/slides/slide4.xml><?xml version="1.0" encoding="utf-8"?>
+<p:sld xmlns:a="http://schemas.openxmlformats.org/drawingml/2006/main" xmlns:p="http://schemas.openxmlformats.org/presentationml/2006/main" xmlns:r="http://schemas.openxmlformats.org/officeDocument/2006/relationships">
+  <p:cSld>
+    <p:spTree>
+      <p:nvGrpSpPr>
+        <p:cNvPr id="1" name=""/>
+        <p:cNvGrpSpPr/>
+        <p:nvPr/>
+      </p:nvGrpSpPr>
+      <p:grpSpPr/>
+      <p:sp>
+        <p:nvSpPr>
+          <p:cNvPr id="2" name="TextBox 1"/>
+          <p:cNvSpPr txBox="1"/>
+          <p:nvPr/>
+        </p:nvSpPr>
+        <p:spPr>
+          <a:xfrm>
+            <a:off x="457200" y="201168"/>
+            <a:ext cx="11247120" cy="457200"/>
+          </a:xfrm>
+          <a:prstGeom prst="rect">
+            <a:avLst/>
+          </a:prstGeom>
+          <a:noFill/>
+        </p:spPr>
+        <p:txBody>
+          <a:bodyPr wrap="square">
+            <a:spAutoFit/>
+          </a:bodyPr>
+          <a:lstStyle/>
+          <a:p>
+            <a:pPr>
+              <a:defRPr sz="2400" b="1">
+                <a:solidFill>
+                  <a:srgbClr val="1B2333"/>
+                </a:solidFill>
+              </a:defRPr>
+            </a:pPr>
+            <a:r>
               <a:t>Backup: reading three depths at once</a:t>
             </a:r>
           </a:p>
@@ -3479,7 +3592,7 @@
 </p:sld>
 </file>
 
-<file path=ppt/slides/slide4.xml><?xml version="1.0" encoding="utf-8"?>
+<file path=ppt/slides/slide5.xml><?xml version="1.0" encoding="utf-8"?>
 <p:sld xmlns:a="http://schemas.openxmlformats.org/drawingml/2006/main" xmlns:p="http://schemas.openxmlformats.org/presentationml/2006/main" xmlns:r="http://schemas.openxmlformats.org/officeDocument/2006/relationships">
   <p:cSld>
     <p:spTree>

</xml_diff>

<commit_message>
Add a slide showing the actual code beside what it produces
Setup and driver loop on the left, the video and the channel-connect line on the
right. Rendered as real text rather than a screenshot so it stays selectable.

The lines are the real functions at the paths in their comments, checked against the
sources. Two deliberate edits for legibility: the type-check branch is dropped, and
variables are shown with the values this run used -- the repo has region and
window_ms, not 'video_mid' and 2000. The caption says so rather than claiming
verbatim, which an earlier draft did and which was false.
</commit_message>
<xml_diff>
--- a/scripts/streaming_demo_output/streaming_deck.pptx
+++ b/scripts/streaming_demo_output/streaming_deck.pptx
@@ -10,6 +10,7 @@
     <p:sldId id="258" r:id="rId9"/>
     <p:sldId id="259" r:id="rId10"/>
     <p:sldId id="260" r:id="rId11"/>
+    <p:sldId id="261" r:id="rId12"/>
   </p:sldIdLst>
   <p:sldSz cx="12191695" cy="6858000" type="screen4x3"/>
   <p:notesSz cx="6858000" cy="9144000"/>
@@ -3489,6 +3490,567 @@
               </a:defRPr>
             </a:pPr>
             <a:r>
+              <a:t>The actual code</a:t>
+            </a:r>
+          </a:p>
+        </p:txBody>
+      </p:sp>
+      <p:sp>
+        <p:nvSpPr>
+          <p:cNvPr id="3" name="TextBox 2"/>
+          <p:cNvSpPr txBox="1"/>
+          <p:nvPr/>
+        </p:nvSpPr>
+        <p:spPr>
+          <a:xfrm>
+            <a:off x="502920" y="777240"/>
+            <a:ext cx="5577840" cy="2286000"/>
+          </a:xfrm>
+          <a:prstGeom prst="rect">
+            <a:avLst/>
+          </a:prstGeom>
+          <a:noFill/>
+        </p:spPr>
+        <p:txBody>
+          <a:bodyPr wrap="square">
+            <a:spAutoFit/>
+          </a:bodyPr>
+          <a:lstStyle/>
+          <a:p>
+            <a:pPr>
+              <a:defRPr sz="1050">
+                <a:solidFill>
+                  <a:srgbClr val="8792A8"/>
+                </a:solidFill>
+                <a:latin typeface="Menlo"/>
+              </a:defRPr>
+            </a:pPr>
+            <a:r>
+              <a:t># unified/scripts/render_streaming_representation.py</a:t>
+            </a:r>
+          </a:p>
+          <a:p>
+            <a:pPr>
+              <a:defRPr sz="1050">
+                <a:solidFill>
+                  <a:srgbClr val="1B2333"/>
+                </a:solidFill>
+                <a:latin typeface="Menlo"/>
+              </a:defRPr>
+            </a:pPr>
+          </a:p>
+          <a:p>
+            <a:pPr>
+              <a:defRPr sz="1050">
+                <a:solidFill>
+                  <a:srgbClr val="1B2333"/>
+                </a:solidFill>
+                <a:latin typeface="Menlo"/>
+              </a:defRPr>
+            </a:pPr>
+            <a:r>
+              <a:t>session = WindowedStreamSession(</a:t>
+            </a:r>
+          </a:p>
+          <a:p>
+            <a:pPr>
+              <a:defRPr sz="1050">
+                <a:solidFill>
+                  <a:srgbClr val="1B2333"/>
+                </a:solidFill>
+                <a:latin typeface="Menlo"/>
+              </a:defRPr>
+            </a:pPr>
+            <a:r>
+              <a:t>    decode_frames(video_path), fps=fps,</a:t>
+            </a:r>
+          </a:p>
+          <a:p>
+            <a:pPr>
+              <a:defRPr sz="1050">
+                <a:solidFill>
+                  <a:srgbClr val="1B2333"/>
+                </a:solidFill>
+                <a:latin typeface="Menlo"/>
+              </a:defRPr>
+            </a:pPr>
+            <a:r>
+              <a:t>    window_ms=2000, stride_ms=500,</a:t>
+            </a:r>
+          </a:p>
+          <a:p>
+            <a:pPr>
+              <a:defRPr sz="1050">
+                <a:solidFill>
+                  <a:srgbClr val="1B2333"/>
+                </a:solidFill>
+                <a:latin typeface="Menlo"/>
+              </a:defRPr>
+            </a:pPr>
+            <a:r>
+              <a:t>    record='video_mid',</a:t>
+            </a:r>
+          </a:p>
+          <a:p>
+            <a:pPr>
+              <a:defRPr sz="1050">
+                <a:solidFill>
+                  <a:srgbClr val="1B2333"/>
+                </a:solidFill>
+                <a:latin typeface="Menlo"/>
+              </a:defRPr>
+            </a:pPr>
+            <a:r>
+              <a:t>    window_to_stimuli=window_to_stimuli)</a:t>
+            </a:r>
+          </a:p>
+          <a:p>
+            <a:pPr>
+              <a:defRPr sz="1050">
+                <a:solidFill>
+                  <a:srgbClr val="1B2333"/>
+                </a:solidFill>
+                <a:latin typeface="Menlo"/>
+              </a:defRPr>
+            </a:pPr>
+          </a:p>
+          <a:p>
+            <a:pPr>
+              <a:defRPr sz="1050">
+                <a:solidFill>
+                  <a:srgbClr val="1B2333"/>
+                </a:solidFill>
+                <a:latin typeface="Menlo"/>
+              </a:defRPr>
+            </a:pPr>
+            <a:r>
+              <a:t>model.start_recording('video_mid')</a:t>
+            </a:r>
+          </a:p>
+          <a:p>
+            <a:pPr>
+              <a:defRPr sz="1050">
+                <a:solidFill>
+                  <a:srgbClr val="1B2333"/>
+                </a:solidFill>
+                <a:latin typeface="Menlo"/>
+              </a:defRPr>
+            </a:pPr>
+            <a:r>
+              <a:t>_drive_neural_session_streaming(model, session)</a:t>
+            </a:r>
+          </a:p>
+        </p:txBody>
+      </p:sp>
+      <p:sp>
+        <p:nvSpPr>
+          <p:cNvPr id="4" name="TextBox 3"/>
+          <p:cNvSpPr txBox="1"/>
+          <p:nvPr/>
+        </p:nvSpPr>
+        <p:spPr>
+          <a:xfrm>
+            <a:off x="502920" y="3063240"/>
+            <a:ext cx="5577840" cy="3017520"/>
+          </a:xfrm>
+          <a:prstGeom prst="rect">
+            <a:avLst/>
+          </a:prstGeom>
+          <a:noFill/>
+        </p:spPr>
+        <p:txBody>
+          <a:bodyPr wrap="square">
+            <a:spAutoFit/>
+          </a:bodyPr>
+          <a:lstStyle/>
+          <a:p>
+            <a:pPr>
+              <a:defRPr sz="1050">
+                <a:solidFill>
+                  <a:srgbClr val="8792A8"/>
+                </a:solidFill>
+                <a:latin typeface="Menlo"/>
+              </a:defRPr>
+            </a:pPr>
+            <a:r>
+              <a:t># core/brainscore_core/streaming_helpers.py</a:t>
+            </a:r>
+          </a:p>
+          <a:p>
+            <a:pPr>
+              <a:defRPr sz="1050">
+                <a:solidFill>
+                  <a:srgbClr val="8792A8"/>
+                </a:solidFill>
+                <a:latin typeface="Menlo"/>
+              </a:defRPr>
+            </a:pPr>
+            <a:r>
+              <a:t>#   _drive_neural_session_streaming</a:t>
+            </a:r>
+          </a:p>
+          <a:p>
+            <a:pPr>
+              <a:defRPr sz="1050">
+                <a:solidFill>
+                  <a:srgbClr val="1B2333"/>
+                </a:solidFill>
+                <a:latin typeface="Menlo"/>
+              </a:defRPr>
+            </a:pPr>
+          </a:p>
+          <a:p>
+            <a:pPr>
+              <a:defRPr sz="1050">
+                <a:solidFill>
+                  <a:srgbClr val="1B2333"/>
+                </a:solidFill>
+                <a:latin typeface="Menlo"/>
+              </a:defRPr>
+            </a:pPr>
+            <a:r>
+              <a:t>event = session.next_input()</a:t>
+            </a:r>
+          </a:p>
+          <a:p>
+            <a:pPr>
+              <a:defRPr sz="1050">
+                <a:solidFill>
+                  <a:srgbClr val="1B2333"/>
+                </a:solidFill>
+                <a:latin typeface="Menlo"/>
+              </a:defRPr>
+            </a:pPr>
+            <a:r>
+              <a:t>while event is not None:</a:t>
+            </a:r>
+          </a:p>
+          <a:p>
+            <a:pPr>
+              <a:defRPr sz="1050">
+                <a:solidFill>
+                  <a:srgbClr val="1B2333"/>
+                </a:solidFill>
+                <a:latin typeface="Menlo"/>
+              </a:defRPr>
+            </a:pPr>
+            <a:r>
+              <a:t>    stimuli = _one_row_stimuli(session, event, stream_index)</a:t>
+            </a:r>
+          </a:p>
+          <a:p>
+            <a:pPr>
+              <a:defRPr sz="1050">
+                <a:solidFill>
+                  <a:srgbClr val="1B2333"/>
+                </a:solidFill>
+                <a:latin typeface="Menlo"/>
+              </a:defRPr>
+            </a:pPr>
+            <a:r>
+              <a:t>    for channel, region in regions:</a:t>
+            </a:r>
+          </a:p>
+          <a:p>
+            <a:pPr>
+              <a:defRPr sz="1050">
+                <a:solidFill>
+                  <a:srgbClr val="1B2333"/>
+                </a:solidFill>
+                <a:latin typeface="Menlo"/>
+              </a:defRPr>
+            </a:pPr>
+            <a:r>
+              <a:t>        _start_recording(subject, region)</a:t>
+            </a:r>
+          </a:p>
+          <a:p>
+            <a:pPr>
+              <a:defRPr sz="1050">
+                <a:solidFill>
+                  <a:srgbClr val="1B2333"/>
+                </a:solidFill>
+                <a:latin typeface="Menlo"/>
+              </a:defRPr>
+            </a:pPr>
+            <a:r>
+              <a:t>        output = subject.process(stimuli)</a:t>
+            </a:r>
+          </a:p>
+          <a:p>
+            <a:pPr>
+              <a:defRPr sz="1050">
+                <a:solidFill>
+                  <a:srgbClr val="1B2333"/>
+                </a:solidFill>
+                <a:latin typeface="Menlo"/>
+              </a:defRPr>
+            </a:pPr>
+            <a:r>
+              <a:t>        session.emit(StreamEvent(</a:t>
+            </a:r>
+          </a:p>
+          <a:p>
+            <a:pPr>
+              <a:defRPr sz="1050">
+                <a:solidFill>
+                  <a:srgbClr val="1B2333"/>
+                </a:solidFill>
+                <a:latin typeface="Menlo"/>
+              </a:defRPr>
+            </a:pPr>
+            <a:r>
+              <a:t>            channel=channel, payload=output,</a:t>
+            </a:r>
+          </a:p>
+          <a:p>
+            <a:pPr>
+              <a:defRPr sz="1050">
+                <a:solidFill>
+                  <a:srgbClr val="1B2333"/>
+                </a:solidFill>
+                <a:latin typeface="Menlo"/>
+              </a:defRPr>
+            </a:pPr>
+            <a:r>
+              <a:t>            t_ms=event.t_ms))</a:t>
+            </a:r>
+          </a:p>
+          <a:p>
+            <a:pPr>
+              <a:defRPr sz="1050">
+                <a:solidFill>
+                  <a:srgbClr val="1B2333"/>
+                </a:solidFill>
+                <a:latin typeface="Menlo"/>
+              </a:defRPr>
+            </a:pPr>
+            <a:r>
+              <a:t>    event = session.next_input()</a:t>
+            </a:r>
+          </a:p>
+        </p:txBody>
+      </p:sp>
+      <p:pic>
+        <p:nvPicPr>
+          <p:cNvPr id="5" name="streaming_channels.mp4">
+            <a:hlinkClick r:id="" action="ppaction://media"/>
+          </p:cNvPr>
+          <p:cNvPicPr>
+            <a:picLocks noChangeAspect="1"/>
+          </p:cNvPicPr>
+          <p:nvPr>
+            <a:videoFile r:link="rId3"/>
+            <p:extLst>
+              <p:ext uri="{DAA4B4D4-6D71-4841-9C94-3DE7FCFB9230}">
+                <p14:media xmlns:p14="http://schemas.microsoft.com/office/powerpoint/2010/main" r:embed="rId2"/>
+              </p:ext>
+            </p:extLst>
+          </p:nvPr>
+        </p:nvPicPr>
+        <p:blipFill>
+          <a:blip r:embed="rId4"/>
+          <a:stretch>
+            <a:fillRect/>
+          </a:stretch>
+        </p:blipFill>
+        <p:spPr>
+          <a:xfrm>
+            <a:off x="6355080" y="1463040"/>
+            <a:ext cx="5394960" cy="2103120"/>
+          </a:xfrm>
+          <a:prstGeom prst="rect">
+            <a:avLst/>
+          </a:prstGeom>
+        </p:spPr>
+      </p:pic>
+      <p:sp>
+        <p:nvSpPr>
+          <p:cNvPr id="6" name="TextBox 5"/>
+          <p:cNvSpPr txBox="1"/>
+          <p:nvPr/>
+        </p:nvSpPr>
+        <p:spPr>
+          <a:xfrm>
+            <a:off x="6355080" y="3931920"/>
+            <a:ext cx="5394960" cy="1828800"/>
+          </a:xfrm>
+          <a:prstGeom prst="rect">
+            <a:avLst/>
+          </a:prstGeom>
+          <a:noFill/>
+        </p:spPr>
+        <p:txBody>
+          <a:bodyPr wrap="square">
+            <a:spAutoFit/>
+          </a:bodyPr>
+          <a:lstStyle/>
+          <a:p>
+            <a:pPr>
+              <a:defRPr sz="1050">
+                <a:solidFill>
+                  <a:srgbClr val="8792A8"/>
+                </a:solidFill>
+                <a:latin typeface="Menlo"/>
+              </a:defRPr>
+            </a:pPr>
+            <a:r>
+              <a:t># adding the second channel</a:t>
+            </a:r>
+          </a:p>
+          <a:p>
+            <a:pPr>
+              <a:defRPr sz="1050">
+                <a:solidFill>
+                  <a:srgbClr val="1B2333"/>
+                </a:solidFill>
+                <a:latin typeface="Menlo"/>
+              </a:defRPr>
+            </a:pPr>
+          </a:p>
+          <a:p>
+            <a:pPr>
+              <a:defRPr sz="1050">
+                <a:solidFill>
+                  <a:srgbClr val="1B2333"/>
+                </a:solidFill>
+                <a:latin typeface="Menlo"/>
+              </a:defRPr>
+            </a:pPr>
+            <a:r>
+              <a:t>model.start_recording(['video_mid', 'audio_mid'])</a:t>
+            </a:r>
+          </a:p>
+          <a:p>
+            <a:pPr>
+              <a:defRPr sz="1050">
+                <a:solidFill>
+                  <a:srgbClr val="1B2333"/>
+                </a:solidFill>
+                <a:latin typeface="Menlo"/>
+              </a:defRPr>
+            </a:pPr>
+          </a:p>
+          <a:p>
+            <a:pPr>
+              <a:defRPr sz="1050">
+                <a:solidFill>
+                  <a:srgbClr val="8792A8"/>
+                </a:solidFill>
+                <a:latin typeface="Menlo"/>
+              </a:defRPr>
+            </a:pPr>
+            <a:r>
+              <a:t># the loop above is unchanged.</a:t>
+            </a:r>
+          </a:p>
+        </p:txBody>
+      </p:sp>
+      <p:sp>
+        <p:nvSpPr>
+          <p:cNvPr id="7" name="TextBox 6"/>
+          <p:cNvSpPr txBox="1"/>
+          <p:nvPr/>
+        </p:nvSpPr>
+        <p:spPr>
+          <a:xfrm>
+            <a:off x="457200" y="6355080"/>
+            <a:ext cx="11247120" cy="411480"/>
+          </a:xfrm>
+          <a:prstGeom prst="rect">
+            <a:avLst/>
+          </a:prstGeom>
+          <a:noFill/>
+        </p:spPr>
+        <p:txBody>
+          <a:bodyPr wrap="square">
+            <a:spAutoFit/>
+          </a:bodyPr>
+          <a:lstStyle/>
+          <a:p>
+            <a:pPr>
+              <a:defRPr sz="1100" b="0">
+                <a:solidFill>
+                  <a:srgbClr val="8792A8"/>
+                </a:solidFill>
+              </a:defRPr>
+            </a:pPr>
+            <a:r>
+              <a:t>These are the real functions, at the paths in their comments. Variables are shown with the values this run used (window_ms=2000, region='video_mid').</a:t>
+            </a:r>
+          </a:p>
+        </p:txBody>
+      </p:sp>
+    </p:spTree>
+  </p:cSld>
+  <p:clrMapOvr>
+    <a:masterClrMapping/>
+  </p:clrMapOvr>
+  <p:timing>
+    <p:tnLst>
+      <p:par>
+        <p:cTn id="1" dur="indefinite" restart="never" nodeType="tmRoot">
+          <p:childTnLst>
+            <p:video>
+              <p:cMediaNode vol="80000">
+                <p:cTn id="2" fill="hold" display="0">
+                  <p:stCondLst>
+                    <p:cond delay="indefinite"/>
+                  </p:stCondLst>
+                </p:cTn>
+                <p:tgtEl>
+                  <p:spTgt spid="5"/>
+                </p:tgtEl>
+              </p:cMediaNode>
+            </p:video>
+          </p:childTnLst>
+        </p:cTn>
+      </p:par>
+    </p:tnLst>
+  </p:timing>
+</p:sld>
+</file>
+
+<file path=ppt/slides/slide5.xml><?xml version="1.0" encoding="utf-8"?>
+<p:sld xmlns:a="http://schemas.openxmlformats.org/drawingml/2006/main" xmlns:p="http://schemas.openxmlformats.org/presentationml/2006/main" xmlns:r="http://schemas.openxmlformats.org/officeDocument/2006/relationships">
+  <p:cSld>
+    <p:spTree>
+      <p:nvGrpSpPr>
+        <p:cNvPr id="1" name=""/>
+        <p:cNvGrpSpPr/>
+        <p:nvPr/>
+      </p:nvGrpSpPr>
+      <p:grpSpPr/>
+      <p:sp>
+        <p:nvSpPr>
+          <p:cNvPr id="2" name="TextBox 1"/>
+          <p:cNvSpPr txBox="1"/>
+          <p:nvPr/>
+        </p:nvSpPr>
+        <p:spPr>
+          <a:xfrm>
+            <a:off x="457200" y="201168"/>
+            <a:ext cx="11247120" cy="457200"/>
+          </a:xfrm>
+          <a:prstGeom prst="rect">
+            <a:avLst/>
+          </a:prstGeom>
+          <a:noFill/>
+        </p:spPr>
+        <p:txBody>
+          <a:bodyPr wrap="square">
+            <a:spAutoFit/>
+          </a:bodyPr>
+          <a:lstStyle/>
+          <a:p>
+            <a:pPr>
+              <a:defRPr sz="2400" b="1">
+                <a:solidFill>
+                  <a:srgbClr val="1B2333"/>
+                </a:solidFill>
+              </a:defRPr>
+            </a:pPr>
+            <a:r>
               <a:t>Backup: reading three depths at once</a:t>
             </a:r>
           </a:p>
@@ -3592,7 +4154,7 @@
 </p:sld>
 </file>
 
-<file path=ppt/slides/slide5.xml><?xml version="1.0" encoding="utf-8"?>
+<file path=ppt/slides/slide6.xml><?xml version="1.0" encoding="utf-8"?>
 <p:sld xmlns:a="http://schemas.openxmlformats.org/drawingml/2006/main" xmlns:p="http://schemas.openxmlformats.org/presentationml/2006/main" xmlns:r="http://schemas.openxmlformats.org/officeDocument/2006/relationships">
   <p:cSld>
     <p:spTree>

</xml_diff>

<commit_message>
Wire audio in mid-session for real, and compute the deck layout from aspect ratios
The demo did not do what its diagram claimed. Video ran over the whole clip, audio ran
over the whole clip separately, and audio_from_window was a RENDER parameter that hid
the first twenty audio windows. The sequence diagram showed a start_recording call at
t=10s that never happened.

Now it is one loop over one clip: video only until tick 20, then the audio feed is
opened and the recording switches per tower each tick. The artifact shows it -- 60
video windows against 40 audio windows -- and run_log.json records both transitions
with their timestamps. The diagram and the code slide describe that, not the intent.

Deck layout was placing pictures and movies at hardcoded inches with no regard for
aspect ratio, which overlapped a 4.5in schematic with a movie by 1.8in. Sizes are now
fitted to each image's real dimensions; verified no overlap and nothing past the
7.5in slide edge.
</commit_message>
<xml_diff>
--- a/scripts/streaming_demo_output/streaming_deck.pptx
+++ b/scripts/streaming_demo_output/streaming_deck.pptx
@@ -3232,8 +3232,8 @@
         </p:blipFill>
         <p:spPr>
           <a:xfrm>
-            <a:off x="457200" y="731520"/>
-            <a:ext cx="11247120" cy="4146930"/>
+            <a:off x="2670766" y="713232"/>
+            <a:ext cx="6819987" cy="2514600"/>
           </a:xfrm>
           <a:prstGeom prst="rect">
             <a:avLst/>
@@ -3265,8 +3265,8 @@
         </p:blipFill>
         <p:spPr>
           <a:xfrm>
-            <a:off x="1920240" y="3246120"/>
-            <a:ext cx="8321040" cy="3200400"/>
+            <a:off x="3452412" y="3392424"/>
+            <a:ext cx="5256695" cy="3200399"/>
           </a:xfrm>
           <a:prstGeom prst="rect">
             <a:avLst/>
@@ -3399,8 +3399,8 @@
         </p:blipFill>
         <p:spPr>
           <a:xfrm>
-            <a:off x="548640" y="777240"/>
-            <a:ext cx="11064240" cy="5693522"/>
+            <a:off x="838738" y="749808"/>
+            <a:ext cx="10484043" cy="5394960"/>
           </a:xfrm>
           <a:prstGeom prst="rect">
             <a:avLst/>
@@ -3856,8 +3856,8 @@
         </p:blipFill>
         <p:spPr>
           <a:xfrm>
-            <a:off x="6355080" y="1463040"/>
-            <a:ext cx="5394960" cy="2103120"/>
+            <a:off x="6355080" y="914400"/>
+            <a:ext cx="4505739" cy="2743200"/>
           </a:xfrm>
           <a:prstGeom prst="rect">
             <a:avLst/>
@@ -3872,7 +3872,7 @@
         </p:nvSpPr>
         <p:spPr>
           <a:xfrm>
-            <a:off x="6355080" y="3931920"/>
+            <a:off x="6355080" y="3886200"/>
             <a:ext cx="5394960" cy="1828800"/>
           </a:xfrm>
           <a:prstGeom prst="rect">
@@ -3895,7 +3895,7 @@
               </a:defRPr>
             </a:pPr>
             <a:r>
-              <a:t># adding the second channel</a:t>
+              <a:t># mid-session, at tick 20 (t = 10 s)</a:t>
             </a:r>
           </a:p>
           <a:p>
@@ -3918,7 +3918,7 @@
               </a:defRPr>
             </a:pPr>
             <a:r>
-              <a:t>model.start_recording(['video_mid', 'audio_mid'])</a:t>
+              <a:t>if i &gt;= CONNECT:</a:t>
             </a:r>
           </a:p>
           <a:p>
@@ -3930,18 +3930,70 @@
                 <a:latin typeface="Menlo"/>
               </a:defRPr>
             </a:pPr>
+            <a:r>
+              <a:t>    seg, sr, t_ms = next(audio_iter)</a:t>
+            </a:r>
           </a:p>
           <a:p>
             <a:pPr>
               <a:defRPr sz="1050">
                 <a:solidFill>
+                  <a:srgbClr val="1B2333"/>
+                </a:solidFill>
+                <a:latin typeface="Menlo"/>
+              </a:defRPr>
+            </a:pPr>
+            <a:r>
+              <a:t>    model.start_recording('encoder.layers.5')</a:t>
+            </a:r>
+          </a:p>
+          <a:p>
+            <a:pPr>
+              <a:defRPr sz="1050">
+                <a:solidFill>
+                  <a:srgbClr val="1B2333"/>
+                </a:solidFill>
+                <a:latin typeface="Menlo"/>
+              </a:defRPr>
+            </a:pPr>
+            <a:r>
+              <a:t>    a = model.process(audio_window)</a:t>
+            </a:r>
+          </a:p>
+          <a:p>
+            <a:pPr>
+              <a:defRPr sz="1050">
+                <a:solidFill>
+                  <a:srgbClr val="1B2333"/>
+                </a:solidFill>
+                <a:latin typeface="Menlo"/>
+              </a:defRPr>
+            </a:pPr>
+            <a:r>
+              <a:t>    model.start_recording('video_mid')</a:t>
+            </a:r>
+          </a:p>
+          <a:p>
+            <a:pPr>
+              <a:defRPr sz="1050">
+                <a:solidFill>
+                  <a:srgbClr val="1B2333"/>
+                </a:solidFill>
+                <a:latin typeface="Menlo"/>
+              </a:defRPr>
+            </a:pPr>
+          </a:p>
+          <a:p>
+            <a:pPr>
+              <a:defRPr sz="1050">
+                <a:solidFill>
                   <a:srgbClr val="8792A8"/>
                 </a:solidFill>
                 <a:latin typeface="Menlo"/>
               </a:defRPr>
             </a:pPr>
             <a:r>
-              <a:t># the loop above is unchanged.</a:t>
+              <a:t># 60 video windows, 40 audio windows.</a:t>
             </a:r>
           </a:p>
         </p:txBody>
@@ -4081,8 +4133,8 @@
         </p:blipFill>
         <p:spPr>
           <a:xfrm>
-            <a:off x="2194560" y="868680"/>
-            <a:ext cx="7772400" cy="4663440"/>
+            <a:off x="2788218" y="822960"/>
+            <a:ext cx="6585082" cy="4663440"/>
           </a:xfrm>
           <a:prstGeom prst="rect">
             <a:avLst/>

</xml_diff>